<commit_message>
Added presenter notes to digram pptx's
</commit_message>
<xml_diff>
--- a/1-WHY_FAMILY/1-Why-Family.pptx
+++ b/1-WHY_FAMILY/1-Why-Family.pptx
@@ -176,7 +176,7 @@
           <a:bodyPr vert="horz" lIns="91440" tIns="45720" rIns="91440" bIns="45720" rtlCol="0"/>
           <a:lstStyle>
             <a:lvl1pPr algn="l">
-              <a:defRPr sz="1200"/>
+              <a:defRPr sz="4200"/>
             </a:lvl1pPr>
           </a:lstStyle>
           <a:p>
@@ -207,7 +207,7 @@
           <a:bodyPr vert="horz" lIns="91440" tIns="45720" rIns="91440" bIns="45720" rtlCol="0"/>
           <a:lstStyle>
             <a:lvl1pPr algn="r">
-              <a:defRPr sz="1200"/>
+              <a:defRPr sz="4200"/>
             </a:lvl1pPr>
           </a:lstStyle>
           <a:p>
@@ -334,7 +334,7 @@
           <a:bodyPr vert="horz" lIns="91440" tIns="45720" rIns="91440" bIns="45720" rtlCol="0" anchor="b"/>
           <a:lstStyle>
             <a:lvl1pPr algn="l">
-              <a:defRPr sz="1200"/>
+              <a:defRPr sz="4200"/>
             </a:lvl1pPr>
           </a:lstStyle>
           <a:p>
@@ -365,7 +365,7 @@
           <a:bodyPr vert="horz" lIns="91440" tIns="45720" rIns="91440" bIns="45720" rtlCol="0" anchor="b"/>
           <a:lstStyle>
             <a:lvl1pPr algn="r">
-              <a:defRPr sz="1200"/>
+              <a:defRPr sz="4200"/>
             </a:lvl1pPr>
           </a:lstStyle>
           <a:p>
@@ -387,7 +387,7 @@
   <p:clrMap bg1="lt1" tx1="dk1" bg2="lt2" tx2="dk2" accent1="accent1" accent2="accent2" accent3="accent3" accent4="accent4" accent5="accent5" accent6="accent6" hlink="hlink" folHlink="folHlink"/>
   <p:notesStyle>
     <a:lvl1pPr marL="0" algn="l" defTabSz="914400" rtl="0" eaLnBrk="1" latinLnBrk="0" hangingPunct="1">
-      <a:defRPr sz="1200" kern="1200">
+      <a:defRPr sz="4200" kern="1200">
         <a:solidFill>
           <a:schemeClr val="tx1"/>
         </a:solidFill>
@@ -397,7 +397,7 @@
       </a:defRPr>
     </a:lvl1pPr>
     <a:lvl2pPr marL="457200" algn="l" defTabSz="914400" rtl="0" eaLnBrk="1" latinLnBrk="0" hangingPunct="1">
-      <a:defRPr sz="1200" kern="1200">
+      <a:defRPr sz="4200" kern="1200">
         <a:solidFill>
           <a:schemeClr val="tx1"/>
         </a:solidFill>
@@ -407,7 +407,7 @@
       </a:defRPr>
     </a:lvl2pPr>
     <a:lvl3pPr marL="914400" algn="l" defTabSz="914400" rtl="0" eaLnBrk="1" latinLnBrk="0" hangingPunct="1">
-      <a:defRPr sz="1200" kern="1200">
+      <a:defRPr sz="4200" kern="1200">
         <a:solidFill>
           <a:schemeClr val="tx1"/>
         </a:solidFill>
@@ -417,7 +417,7 @@
       </a:defRPr>
     </a:lvl3pPr>
     <a:lvl4pPr marL="1371600" algn="l" defTabSz="914400" rtl="0" eaLnBrk="1" latinLnBrk="0" hangingPunct="1">
-      <a:defRPr sz="1200" kern="1200">
+      <a:defRPr sz="4200" kern="1200">
         <a:solidFill>
           <a:schemeClr val="tx1"/>
         </a:solidFill>
@@ -427,7 +427,7 @@
       </a:defRPr>
     </a:lvl4pPr>
     <a:lvl5pPr marL="1828800" algn="l" defTabSz="914400" rtl="0" eaLnBrk="1" latinLnBrk="0" hangingPunct="1">
-      <a:defRPr sz="1200" kern="1200">
+      <a:defRPr sz="4200" kern="1200">
         <a:solidFill>
           <a:schemeClr val="tx1"/>
         </a:solidFill>
@@ -437,7 +437,7 @@
       </a:defRPr>
     </a:lvl5pPr>
     <a:lvl6pPr marL="2286000" algn="l" defTabSz="914400" rtl="0" eaLnBrk="1" latinLnBrk="0" hangingPunct="1">
-      <a:defRPr sz="1200" kern="1200">
+      <a:defRPr sz="4200" kern="1200">
         <a:solidFill>
           <a:schemeClr val="tx1"/>
         </a:solidFill>
@@ -447,7 +447,7 @@
       </a:defRPr>
     </a:lvl6pPr>
     <a:lvl7pPr marL="2743200" algn="l" defTabSz="914400" rtl="0" eaLnBrk="1" latinLnBrk="0" hangingPunct="1">
-      <a:defRPr sz="1200" kern="1200">
+      <a:defRPr sz="4200" kern="1200">
         <a:solidFill>
           <a:schemeClr val="tx1"/>
         </a:solidFill>
@@ -457,7 +457,7 @@
       </a:defRPr>
     </a:lvl7pPr>
     <a:lvl8pPr marL="3200400" algn="l" defTabSz="914400" rtl="0" eaLnBrk="1" latinLnBrk="0" hangingPunct="1">
-      <a:defRPr sz="1200" kern="1200">
+      <a:defRPr sz="4200" kern="1200">
         <a:solidFill>
           <a:schemeClr val="tx1"/>
         </a:solidFill>
@@ -467,7 +467,7 @@
       </a:defRPr>
     </a:lvl8pPr>
     <a:lvl9pPr marL="3657600" algn="l" defTabSz="914400" rtl="0" eaLnBrk="1" latinLnBrk="0" hangingPunct="1">
-      <a:defRPr sz="1200" kern="1200">
+      <a:defRPr sz="4200" kern="1200">
         <a:solidFill>
           <a:schemeClr val="tx1"/>
         </a:solidFill>
@@ -525,10 +525,21 @@
           <a:lstStyle/>
           <a:p>
             <a:r>
-              <a:rPr lang="en-US" dirty="0"/>
-              <a:t/>
-            </a:r>
-            <a:endParaRPr lang="en-US" dirty="0"/>
+              <a:rPr sz="4200"/>
+              <a:t>TITLE SLIDE</a:t>
+            </a:r>
+          </a:p>
+          <a:p>
+            <a:r>
+              <a:rPr sz="4200"/>
+              <a:t>"Why Family? The State of Behavioral Health"</a:t>
+            </a:r>
+          </a:p>
+          <a:p>
+            <a:r>
+              <a:rPr sz="4200"/>
+              <a:t>Presentation 1 of 5. Sets up the scientific problems in behavioral health field.</a:t>
+            </a:r>
           </a:p>
         </p:txBody>
       </p:sp>
@@ -613,10 +624,33 @@
           <a:lstStyle/>
           <a:p>
             <a:r>
-              <a:rPr lang="en-US" dirty="0"/>
-              <a:t/>
-            </a:r>
-            <a:endParaRPr lang="en-US" dirty="0"/>
+              <a:rPr sz="4200"/>
+              <a:t>SALEM WITCH TRIALS (1692)</a:t>
+            </a:r>
+          </a:p>
+          <a:p>
+            <a:r>
+              <a:rPr sz="4200"/>
+              <a:t>The Belief: Witches identifiable by symptoms and accusations.</a:t>
+            </a:r>
+          </a:p>
+          <a:p>
+            <a:r>
+              <a:rPr sz="4200"/>
+              <a:t>The Evidence: Spectral evidence, fits, accusations.</a:t>
+            </a:r>
+          </a:p>
+          <a:p>
+            <a:r>
+              <a:rPr sz="4200"/>
+              <a:t>The Outcome: 25+ dead, 200+ accused, families destroyed.</a:t>
+            </a:r>
+          </a:p>
+          <a:p>
+            <a:r>
+              <a:rPr sz="4200"/>
+              <a:t>The End: Within years, jurors signed public apologies.</a:t>
+            </a:r>
           </a:p>
         </p:txBody>
       </p:sp>
@@ -701,10 +735,45 @@
           <a:lstStyle/>
           <a:p>
             <a:r>
-              <a:rPr lang="en-US" dirty="0"/>
-              <a:t/>
-            </a:r>
-            <a:endParaRPr lang="en-US" dirty="0"/>
+              <a:rPr sz="4200"/>
+              <a:t>LOBOTOMY EPIDEMIC (1940s-1950s)</a:t>
+            </a:r>
+          </a:p>
+          <a:p>
+            <a:r>
+              <a:rPr sz="4200"/>
+              <a:t>The Belief: Mental illness cured by severing brain connections.</a:t>
+            </a:r>
+          </a:p>
+          <a:p>
+            <a:r>
+              <a:rPr sz="4200"/>
+              <a:t>The Evidence: Patients seemed "calmer."</a:t>
+            </a:r>
+          </a:p>
+          <a:p>
+            <a:r>
+              <a:rPr sz="4200"/>
+              <a:t>50,000+ lobotomies in the US. ~5% mortality rate. Thousands permanently damaged.</a:t>
+            </a:r>
+          </a:p>
+          <a:p>
+            <a:r>
+              <a:rPr sz="4200"/>
+              <a:t>Walter Freeman performed 4,000 personally—on patients as young as 4.</a:t>
+            </a:r>
+          </a:p>
+          <a:p>
+            <a:r>
+              <a:rPr sz="4200"/>
+              <a:t>Rosemary Kennedy permanently incapacitated.</a:t>
+            </a:r>
+          </a:p>
+          <a:p>
+            <a:r>
+              <a:rPr sz="4200"/>
+              <a:t>Freeman celebrated—until banned. Soviet Union banned it in 1950.</a:t>
+            </a:r>
           </a:p>
         </p:txBody>
       </p:sp>
@@ -789,10 +858,33 @@
           <a:lstStyle/>
           <a:p>
             <a:r>
-              <a:rPr lang="en-US" dirty="0"/>
-              <a:t/>
-            </a:r>
-            <a:endParaRPr lang="en-US" dirty="0"/>
+              <a:rPr sz="4200"/>
+              <a:t>REFRIGERATOR MOTHER THEORY (1950s-1970s)</a:t>
+            </a:r>
+          </a:p>
+          <a:p>
+            <a:r>
+              <a:rPr sz="4200"/>
+              <a:t>The Belief: Autism caused by cold, unloving mothers.</a:t>
+            </a:r>
+          </a:p>
+          <a:p>
+            <a:r>
+              <a:rPr sz="4200"/>
+              <a:t>The Evidence: Psychoanalytic interpretation.</a:t>
+            </a:r>
+          </a:p>
+          <a:p>
+            <a:r>
+              <a:rPr sz="4200"/>
+              <a:t>20 years blaming mothers. Immense guilt. Children institutionalized.</a:t>
+            </a:r>
+          </a:p>
+          <a:p>
+            <a:r>
+              <a:rPr sz="4200"/>
+              <a:t>Bettelheim (main proponent) exposed as fraud who lied about credentials and abused patients.</a:t>
+            </a:r>
           </a:p>
         </p:txBody>
       </p:sp>
@@ -877,10 +969,39 @@
           <a:lstStyle/>
           <a:p>
             <a:r>
-              <a:rPr lang="en-US" dirty="0"/>
-              <a:t/>
-            </a:r>
-            <a:endParaRPr lang="en-US" dirty="0"/>
+              <a:rPr sz="4200"/>
+              <a:t>RECOVERED MEMORY THERAPY (1980s-1990s)</a:t>
+            </a:r>
+          </a:p>
+          <a:p>
+            <a:r>
+              <a:rPr sz="4200"/>
+              <a:t>The Belief: Repressed memories recoverable through therapy.</a:t>
+            </a:r>
+          </a:p>
+          <a:p>
+            <a:r>
+              <a:rPr sz="4200"/>
+              <a:t>The Evidence: Patients "remembered" under guidance.</a:t>
+            </a:r>
+          </a:p>
+          <a:p>
+            <a:r>
+              <a:rPr sz="4200"/>
+              <a:t>Est. 1 million patients convinced they had repressed memories.</a:t>
+            </a:r>
+          </a:p>
+          <a:p>
+            <a:r>
+              <a:rPr sz="4200"/>
+              <a:t>"Tens of thousands of families" destroyed. People imprisoned on false accusations.</a:t>
+            </a:r>
+          </a:p>
+          <a:p>
+            <a:r>
+              <a:rPr sz="4200"/>
+              <a:t>Malpractice suits, license revocations. FBI found zero evidence of satanic abuse.</a:t>
+            </a:r>
           </a:p>
         </p:txBody>
       </p:sp>
@@ -965,10 +1086,21 @@
           <a:lstStyle/>
           <a:p>
             <a:r>
-              <a:rPr lang="en-US" dirty="0"/>
-              <a:t/>
-            </a:r>
-            <a:endParaRPr lang="en-US" dirty="0"/>
+              <a:rPr sz="4200"/>
+              <a:t>SATANIC PANIC / DAYCARE ABUSE + MPD/DID EPIDEMIC (1980s-1990s)</a:t>
+            </a:r>
+          </a:p>
+          <a:p>
+            <a:r>
+              <a:rPr sz="4200"/>
+              <a:t>Satanic Panic: 12,000+ cases alleged. McMartin: 7 years, $15M, zero convictions. FBI found no evidence.</a:t>
+            </a:r>
+          </a:p>
+          <a:p>
+            <a:r>
+              <a:rPr sz="4200"/>
+              <a:t>MPD/DID: 50,000 diagnoses by 1990s (vs. ~200 in all prior history). Patients got worse. Largely iatrogenic—created by the therapy. Epidemic disappeared when practices stopped.</a:t>
+            </a:r>
           </a:p>
         </p:txBody>
       </p:sp>
@@ -1053,10 +1185,15 @@
           <a:lstStyle/>
           <a:p>
             <a:r>
-              <a:rPr lang="en-US" dirty="0"/>
-              <a:t/>
-            </a:r>
-            <a:endParaRPr lang="en-US" dirty="0"/>
+              <a:rPr sz="4200"/>
+              <a:t>THE COMMON PATTERN</a:t>
+            </a:r>
+          </a:p>
+          <a:p>
+            <a:r>
+              <a:rPr sz="4200"/>
+              <a:t>All cases share: No objective evidence, no way to test validity, emotion as the glue (fear, care, outrage), spread through professionals, ended in calamity.</a:t>
+            </a:r>
           </a:p>
         </p:txBody>
       </p:sp>
@@ -1141,10 +1278,39 @@
           <a:lstStyle/>
           <a:p>
             <a:r>
-              <a:rPr lang="en-US" dirty="0"/>
-              <a:t/>
-            </a:r>
-            <a:endParaRPr lang="en-US" dirty="0"/>
+              <a:rPr sz="4200"/>
+              <a:t>WHAT ABOUT NOW?</a:t>
+            </a:r>
+          </a:p>
+          <a:p>
+            <a:r>
+              <a:rPr sz="4200"/>
+              <a:t>"I want to pause and invite you to wonder: What social contagions might be happening right now? What topics feel off-limits to question? What beliefs are held with such emotional intensity that questioning them makes you suspect?"</a:t>
+            </a:r>
+          </a:p>
+          <a:p>
+            <a:r>
+              <a:rPr sz="4200"/>
+              <a:t>"I'm not going to name them. You can think of your own."</a:t>
+            </a:r>
+          </a:p>
+          <a:p>
+            <a:r>
+              <a:rPr sz="4200"/>
+              <a:t>"But I want to be clear: I have deep respect for the power of these forces. They are not to be taken lightly. They are not an invitation to convenient rebellion."</a:t>
+            </a:r>
+          </a:p>
+          <a:p>
+            <a:r>
+              <a:rPr sz="4200"/>
+              <a:t>"These forces are real. They serve a function—I believe a biological function. The question is not whether they exist, but whether we can recognize them and respond more thoughtfully than our ancestors did."</a:t>
+            </a:r>
+          </a:p>
+          <a:p>
+            <a:r>
+              <a:rPr sz="4200"/>
+              <a:t>Transition: "Which brings us to: Why does this keep happening?"</a:t>
+            </a:r>
           </a:p>
         </p:txBody>
       </p:sp>
@@ -1229,10 +1395,15 @@
           <a:lstStyle/>
           <a:p>
             <a:r>
-              <a:rPr lang="en-US" dirty="0"/>
-              <a:t/>
-            </a:r>
-            <a:endParaRPr lang="en-US" dirty="0"/>
+              <a:rPr sz="4200"/>
+              <a:t>SECTION IV: WHY THIS KEEPS HAPPENING (12 min)</a:t>
+            </a:r>
+          </a:p>
+          <a:p>
+            <a:r>
+              <a:rPr sz="4200"/>
+              <a:t>This section covers the anxiety mechanism that drives these contagions.</a:t>
+            </a:r>
           </a:p>
         </p:txBody>
       </p:sp>
@@ -1317,10 +1488,84 @@
           <a:lstStyle/>
           <a:p>
             <a:r>
-              <a:rPr lang="en-US" dirty="0"/>
-              <a:t/>
-            </a:r>
-            <a:endParaRPr lang="en-US" dirty="0"/>
+              <a:rPr sz="4200"/>
+              <a:t>ANXIETY = PERCEIVED UNCERTAINTY + URGENCY</a:t>
+            </a:r>
+          </a:p>
+          <a:p>
+            <a:r>
+              <a:rPr sz="4200"/>
+              <a:t>Core concept (the "A" in SARF): Anxiety occurs when people perceive uncertainty combined with urgency.</a:t>
+            </a:r>
+          </a:p>
+          <a:p>
+            <a:r>
+              <a:rPr sz="4200"/>
+              <a:t>When anxious, the first thing people do is look for a way to reduce uncertainty. Any explanation feels better than no explanation.</a:t>
+            </a:r>
+          </a:p>
+          <a:p/>
+          <a:p>
+            <a:r>
+              <a:rPr sz="4200"/>
+              <a:t>THE IDEOLOGY PROVIDES RELIEF:</a:t>
+            </a:r>
+          </a:p>
+          <a:p>
+            <a:r>
+              <a:rPr sz="4200"/>
+              <a:t>What all contagions have in common—they offer an explanation that is:</a:t>
+            </a:r>
+          </a:p>
+          <a:p>
+            <a:r>
+              <a:rPr sz="4200"/>
+              <a:t>1. Untestable (unassailable—you can't prove it wrong)</a:t>
+            </a:r>
+          </a:p>
+          <a:p>
+            <a:r>
+              <a:rPr sz="4200"/>
+              <a:t>2. Simple (but oversimplified)</a:t>
+            </a:r>
+          </a:p>
+          <a:p>
+            <a:r>
+              <a:rPr sz="4200"/>
+              <a:t>This cuts the uncertainty. People perceive uncertainty has gone away. They calm down.</a:t>
+            </a:r>
+          </a:p>
+          <a:p>
+            <a:r>
+              <a:rPr sz="4200"/>
+              <a:t>"The ideology provides psychological relief. The believers feel better. That's why it spreads."</a:t>
+            </a:r>
+          </a:p>
+          <a:p/>
+          <a:p>
+            <a:r>
+              <a:rPr sz="4200"/>
+              <a:t>Short-term: ideology solves the suffering of anxiety for believers.</a:t>
+            </a:r>
+          </a:p>
+          <a:p>
+            <a:r>
+              <a:rPr sz="4200"/>
+              <a:t>Long-term: it obscures the true problem—which is that these problems aren't well understood.</a:t>
+            </a:r>
+          </a:p>
+          <a:p>
+            <a:r>
+              <a:rPr sz="4200"/>
+              <a:t>The anxious response creates more damage than the original problem.</a:t>
+            </a:r>
+          </a:p>
+          <a:p/>
+          <a:p>
+            <a:r>
+              <a:rPr sz="4200"/>
+              <a:t>Band-aid analogy: One person applies a band-aid calmly. Another runs screaming, breaks furniture, spouse leaves the stove on, burns the house down.</a:t>
+            </a:r>
           </a:p>
         </p:txBody>
       </p:sp>
@@ -1405,10 +1650,73 @@
           <a:lstStyle/>
           <a:p>
             <a:r>
-              <a:rPr lang="en-US" dirty="0"/>
-              <a:t/>
-            </a:r>
-            <a:endParaRPr lang="en-US" dirty="0"/>
+              <a:rPr sz="4200"/>
+              <a:t>CAMBRIDGE-SOMERVILLE YOUTH STUDY</a:t>
+            </a:r>
+          </a:p>
+          <a:p>
+            <a:r>
+              <a:rPr sz="4200"/>
+              <a:t>506 boys, matched pairs, random assignment. Treatment: counseling, mentorship, summer camp, caring adults.</a:t>
+            </a:r>
+          </a:p>
+          <a:p>
+            <a:r>
+              <a:rPr sz="4200"/>
+              <a:t>30-year result: treatment group had more criminal offending, more alcohol abuse, more mental illness, lower job satisfaction, earlier death.</a:t>
+            </a:r>
+          </a:p>
+          <a:p/>
+          <a:p>
+            <a:r>
+              <a:rPr sz="4200"/>
+              <a:t>Joan McCord: "No one had ever discussed the possibility that intervention... that there is any potential for harmful effects."</a:t>
+            </a:r>
+          </a:p>
+          <a:p>
+            <a:r>
+              <a:rPr sz="4200"/>
+              <a:t>"Unless social programs are evaluated for potential harm as well as benefit, safety as well as efficacy, the choice of which social programs to use will remain a dangerous guess."</a:t>
+            </a:r>
+          </a:p>
+          <a:p/>
+          <a:p>
+            <a:r>
+              <a:rPr sz="4200"/>
+              <a:t>Also: DARE (80% of schools, no effect), Scared Straight (kids did worse).</a:t>
+            </a:r>
+          </a:p>
+          <a:p>
+            <a:r>
+              <a:rPr sz="4200"/>
+              <a:t>Key line: "Caring isn't enough. Without measurement, caring can hurt."</a:t>
+            </a:r>
+          </a:p>
+          <a:p/>
+          <a:p>
+            <a:r>
+              <a:rPr sz="4200"/>
+              <a:t>WHY CARING PROFESSIONS ARE ESPECIALLY VULNERABLE:</a:t>
+            </a:r>
+          </a:p>
+          <a:p>
+            <a:r>
+              <a:rPr sz="4200"/>
+              <a:t>Caring professions attract people who want to help. Suffering creates urgency. Uncertainty about what works is intolerable. Any framework that promises clarity is appealing. Questioning the framework feels like abandoning the suffering.</a:t>
+            </a:r>
+          </a:p>
+          <a:p/>
+          <a:p>
+            <a:r>
+              <a:rPr sz="4200"/>
+              <a:t>WITHOUT MEASUREMENT, SOCIAL DYNAMICS RULE:</a:t>
+            </a:r>
+          </a:p>
+          <a:p>
+            <a:r>
+              <a:rPr sz="4200"/>
+              <a:t>Concepts spread based on who promotes them, how they feel, what's socially safe to say. Once belief sets in, questioning makes you a heretic. Traditional perspectives that emphasize autonomy/accountability become unmentionable.</a:t>
+            </a:r>
           </a:p>
         </p:txBody>
       </p:sp>
@@ -1493,10 +1801,39 @@
           <a:lstStyle/>
           <a:p>
             <a:r>
-              <a:rPr lang="en-US" dirty="0"/>
-              <a:t/>
-            </a:r>
-            <a:endParaRPr lang="en-US" dirty="0"/>
+              <a:rPr sz="4200"/>
+              <a:t>SECTION I: THE ENGINEER'S CONFESSION (3 min)</a:t>
+            </a:r>
+          </a:p>
+          <a:p>
+            <a:r>
+              <a:rPr sz="4200"/>
+              <a:t>Your story: engineer enters behavioral health field.</a:t>
+            </a:r>
+          </a:p>
+          <a:p>
+            <a:r>
+              <a:rPr sz="4200"/>
+              <a:t>Expected: if it doesn't work, measure it, fix it, or discard it.</a:t>
+            </a:r>
+          </a:p>
+          <a:p>
+            <a:r>
+              <a:rPr sz="4200"/>
+              <a:t>Found: a field that doesn't work that way.</a:t>
+            </a:r>
+          </a:p>
+          <a:p>
+            <a:r>
+              <a:rPr sz="4200"/>
+              <a:t>"I'm not here to attack anyone's training. I'm here to make a case that everyone—not just engineers—needs scientific thinking."</a:t>
+            </a:r>
+          </a:p>
+          <a:p>
+            <a:r>
+              <a:rPr sz="4200"/>
+              <a:t>Transition: "Let me show you the data."</a:t>
+            </a:r>
           </a:p>
         </p:txBody>
       </p:sp>
@@ -1581,10 +1918,21 @@
           <a:lstStyle/>
           <a:p>
             <a:r>
-              <a:rPr lang="en-US" dirty="0"/>
-              <a:t/>
-            </a:r>
-            <a:endParaRPr lang="en-US" dirty="0"/>
+              <a:rPr sz="4200"/>
+              <a:t>SECTION V: THE PROPOSAL (13 min)</a:t>
+            </a:r>
+          </a:p>
+          <a:p>
+            <a:r>
+              <a:rPr sz="4200"/>
+              <a:t>Scientific thinking is the antidote. The willingness to be falsified.</a:t>
+            </a:r>
+          </a:p>
+          <a:p>
+            <a:r>
+              <a:rPr sz="4200"/>
+              <a:t>"A field that doesn't ask 'what if we're wrong?' will eventually be wrong in catastrophic ways."</a:t>
+            </a:r>
           </a:p>
         </p:txBody>
       </p:sp>
@@ -1669,10 +2017,27 @@
           <a:lstStyle/>
           <a:p>
             <a:r>
-              <a:rPr lang="en-US" dirty="0"/>
-              <a:t/>
-            </a:r>
-            <a:endParaRPr lang="en-US" dirty="0"/>
+              <a:rPr sz="4200"/>
+              <a:t>THE BLADE OF GRASS</a:t>
+            </a:r>
+          </a:p>
+          <a:p>
+            <a:r>
+              <a:rPr sz="4200"/>
+              <a:t>Studying a blade of grass to understand why it bends. Measuring angle, position, structure. Still can't predict movement.</a:t>
+            </a:r>
+          </a:p>
+          <a:p>
+            <a:r>
+              <a:rPr sz="4200"/>
+              <a:t>Because the grass isn't the phenomenon. The wind is.</a:t>
+            </a:r>
+          </a:p>
+          <a:p>
+            <a:r>
+              <a:rPr sz="4200"/>
+              <a:t>"We've spent 80 years studying individuals. The pattern is in the system."</a:t>
+            </a:r>
           </a:p>
         </p:txBody>
       </p:sp>
@@ -1757,10 +2122,27 @@
           <a:lstStyle/>
           <a:p>
             <a:r>
-              <a:rPr lang="en-US" dirty="0"/>
-              <a:t/>
-            </a:r>
-            <a:endParaRPr lang="en-US" dirty="0"/>
+              <a:rPr sz="4200"/>
+              <a:t>WHY FAMILY?</a:t>
+            </a:r>
+          </a:p>
+          <a:p>
+            <a:r>
+              <a:rPr sz="4200"/>
+              <a:t>Family is the smallest system where the pattern is visible.</a:t>
+            </a:r>
+          </a:p>
+          <a:p>
+            <a:r>
+              <a:rPr sz="4200"/>
+              <a:t>Not society (too big, can't intervene). Not the individual (misses the pattern).</a:t>
+            </a:r>
+          </a:p>
+          <a:p>
+            <a:r>
+              <a:rPr sz="4200"/>
+              <a:t>One level up from the blade of grass.</a:t>
+            </a:r>
           </a:p>
         </p:txBody>
       </p:sp>
@@ -1845,10 +2227,34 @@
           <a:lstStyle/>
           <a:p>
             <a:r>
-              <a:rPr lang="en-US" dirty="0"/>
-              <a:t/>
-            </a:r>
-            <a:endParaRPr lang="en-US" dirty="0"/>
+              <a:rPr sz="4200"/>
+              <a:t>FACTS CALM PEOPLE DOWN</a:t>
+            </a:r>
+          </a:p>
+          <a:p>
+            <a:r>
+              <a:rPr sz="4200"/>
+              <a:t>The Common Currency Argument: Everyone knows what a dollar is → global markets. Without common currency → barter → no coordination.</a:t>
+            </a:r>
+          </a:p>
+          <a:p>
+            <a:r>
+              <a:rPr sz="4200"/>
+              <a:t>Without measurable concepts → opinion vs. opinion → loudest voice wins.</a:t>
+            </a:r>
+          </a:p>
+          <a:p/>
+          <a:p>
+            <a:r>
+              <a:rPr sz="4200"/>
+              <a:t>First move in family therapy: gather facts. What is a fact? Something everyone can easily agree on. Facts establish a depolarized baseline.</a:t>
+            </a:r>
+          </a:p>
+          <a:p>
+            <a:r>
+              <a:rPr sz="4200"/>
+              <a:t>"Measurability provides a healthier way to reduce uncertainty than ideology. Facts calm people down without the catastrophic side effects."</a:t>
+            </a:r>
           </a:p>
         </p:txBody>
       </p:sp>
@@ -1933,10 +2339,39 @@
           <a:lstStyle/>
           <a:p>
             <a:r>
-              <a:rPr lang="en-US" dirty="0"/>
-              <a:t/>
-            </a:r>
-            <a:endParaRPr lang="en-US" dirty="0"/>
+              <a:rPr sz="4200"/>
+              <a:t>WHAT YOU'LL GET TODAY</a:t>
+            </a:r>
+          </a:p>
+          <a:p>
+            <a:r>
+              <a:rPr sz="4200"/>
+              <a:t>Preview of the day's remaining sessions:</a:t>
+            </a:r>
+          </a:p>
+          <a:p>
+            <a:r>
+              <a:rPr sz="4200"/>
+              <a:t>- SARF: Measurable concepts for family-level patterns—including "A" for anxiety</a:t>
+            </a:r>
+          </a:p>
+          <a:p>
+            <a:r>
+              <a:rPr sz="4200"/>
+              <a:t>- AI Tools: Technology to capture what we're learning to see</a:t>
+            </a:r>
+          </a:p>
+          <a:p>
+            <a:r>
+              <a:rPr sz="4200"/>
+              <a:t>- App Demo: Practical tools you can use Monday</a:t>
+            </a:r>
+          </a:p>
+          <a:p>
+            <a:r>
+              <a:rPr sz="4200"/>
+              <a:t>- Clinical Case: Evidence it works</a:t>
+            </a:r>
           </a:p>
         </p:txBody>
       </p:sp>
@@ -2021,10 +2456,52 @@
           <a:lstStyle/>
           <a:p>
             <a:r>
-              <a:rPr lang="en-US" dirty="0"/>
-              <a:t/>
-            </a:r>
-            <a:endParaRPr lang="en-US" dirty="0"/>
+              <a:rPr sz="4200"/>
+              <a:t>CLOSING / CALL TO ACTION</a:t>
+            </a:r>
+          </a:p>
+          <a:p>
+            <a:r>
+              <a:rPr sz="4200"/>
+              <a:t>"Everyone needs scientific thinking."</a:t>
+            </a:r>
+          </a:p>
+          <a:p>
+            <a:r>
+              <a:rPr sz="4200"/>
+              <a:t>"Before your next intake, draw the family."</a:t>
+            </a:r>
+          </a:p>
+          <a:p>
+            <a:r>
+              <a:rPr sz="4200"/>
+              <a:t>"Before your next intervention, ask: how would I know if this is making things worse?"</a:t>
+            </a:r>
+          </a:p>
+          <a:p/>
+          <a:p>
+            <a:r>
+              <a:rPr sz="4200"/>
+              <a:t>Q&amp;A follows (10 min). Likely questions:</a:t>
+            </a:r>
+          </a:p>
+          <a:p>
+            <a:r>
+              <a:rPr sz="4200"/>
+              <a:t>- "Are you saying therapy doesn't work?"</a:t>
+            </a:r>
+          </a:p>
+          <a:p>
+            <a:r>
+              <a:rPr sz="4200"/>
+              <a:t>- "What about individual factors like genetics?"</a:t>
+            </a:r>
+          </a:p>
+          <a:p>
+            <a:r>
+              <a:rPr sz="4200"/>
+              <a:t>- "How do I apply scientific thinking without being a researcher?"</a:t>
+            </a:r>
           </a:p>
         </p:txBody>
       </p:sp>
@@ -2109,10 +2586,21 @@
           <a:lstStyle/>
           <a:p>
             <a:r>
-              <a:rPr lang="en-US" dirty="0"/>
-              <a:t/>
-            </a:r>
-            <a:endParaRPr lang="en-US" dirty="0"/>
+              <a:rPr sz="4200"/>
+              <a:t>SECTION II: THE FIELD IS BROKEN (8 min)</a:t>
+            </a:r>
+          </a:p>
+          <a:p>
+            <a:r>
+              <a:rPr sz="4200"/>
+              <a:t>This section presents the data showing the field is broken.</a:t>
+            </a:r>
+          </a:p>
+          <a:p>
+            <a:r>
+              <a:rPr sz="4200"/>
+              <a:t>Scope note: "I'll be speaking in the context of clinical psychology since it's a formalized domain with the most concrete examples. But these patterns apply across all helping professions—LCSW, LPC, MFT, and others."</a:t>
+            </a:r>
           </a:p>
         </p:txBody>
       </p:sp>
@@ -2197,10 +2685,39 @@
           <a:lstStyle/>
           <a:p>
             <a:r>
-              <a:rPr lang="en-US" dirty="0"/>
-              <a:t/>
-            </a:r>
-            <a:endParaRPr lang="en-US" dirty="0"/>
+              <a:rPr sz="4200"/>
+              <a:t>THE TREATMENT-PREVALENCE PARADOX (Centerpiece)</a:t>
+            </a:r>
+          </a:p>
+          <a:p>
+            <a:r>
+              <a:rPr sz="4200"/>
+              <a:t>Source: Ormel et al. (2022)</a:t>
+            </a:r>
+          </a:p>
+          <a:p>
+            <a:r>
+              <a:rPr sz="4200"/>
+              <a:t>Treatment for depression increased 4x from 1987-2007.</a:t>
+            </a:r>
+          </a:p>
+          <a:p>
+            <a:r>
+              <a:rPr sz="4200"/>
+              <a:t>Prevalence of depression: stayed the same or increased.</a:t>
+            </a:r>
+          </a:p>
+          <a:p>
+            <a:r>
+              <a:rPr sz="4200"/>
+              <a:t>Researchers' conclusion: "Significant prevalence reduction requires not only better treatment but foremost long-term structurally funded prevention targeting powerful determinants."</a:t>
+            </a:r>
+          </a:p>
+          <a:p>
+            <a:r>
+              <a:rPr sz="4200"/>
+              <a:t>Key line: "More treatment does not mean less depression."</a:t>
+            </a:r>
           </a:p>
         </p:txBody>
       </p:sp>
@@ -2285,10 +2802,33 @@
           <a:lstStyle/>
           <a:p>
             <a:r>
-              <a:rPr lang="en-US" dirty="0"/>
-              <a:t/>
-            </a:r>
-            <a:endParaRPr lang="en-US" dirty="0"/>
+              <a:rPr sz="4200"/>
+              <a:t>THE RELAPSE PROBLEM</a:t>
+            </a:r>
+          </a:p>
+          <a:p>
+            <a:r>
+              <a:rPr sz="4200"/>
+              <a:t>Sources: BMC Psychiatry, BJGP</a:t>
+            </a:r>
+          </a:p>
+          <a:p>
+            <a:r>
+              <a:rPr sz="4200"/>
+              <a:t>After first episode: 50% relapse. After second: 70%. After third: 90%.</a:t>
+            </a:r>
+          </a:p>
+          <a:p>
+            <a:r>
+              <a:rPr sz="4200"/>
+              <a:t>85% recurrence within a decade. 79% of relapses within first 6 months.</a:t>
+            </a:r>
+          </a:p>
+          <a:p>
+            <a:r>
+              <a:rPr sz="4200"/>
+              <a:t>Key line: "The fire keeps getting relit."</a:t>
+            </a:r>
           </a:p>
         </p:txBody>
       </p:sp>
@@ -2373,10 +2913,45 @@
           <a:lstStyle/>
           <a:p>
             <a:r>
-              <a:rPr lang="en-US" dirty="0"/>
-              <a:t/>
-            </a:r>
-            <a:endParaRPr lang="en-US" dirty="0"/>
+              <a:rPr sz="4200"/>
+              <a:t>THE YOUTH CRISIS</a:t>
+            </a:r>
+          </a:p>
+          <a:p>
+            <a:r>
+              <a:rPr sz="4200"/>
+              <a:t>Sources: CDC MMWR 2023, JED Foundation</a:t>
+            </a:r>
+          </a:p>
+          <a:p>
+            <a:r>
+              <a:rPr sz="4200"/>
+              <a:t>Teen depression: 145% increase (2010-2021).</a:t>
+            </a:r>
+          </a:p>
+          <a:p>
+            <a:r>
+              <a:rPr sz="4200"/>
+              <a:t>Suicide deaths ages 10-24: 62% increase (2007-2021).</a:t>
+            </a:r>
+          </a:p>
+          <a:p>
+            <a:r>
+              <a:rPr sz="4200"/>
+              <a:t>1 in 5 high school students seriously considered suicide in 2023.</a:t>
+            </a:r>
+          </a:p>
+          <a:p>
+            <a:r>
+              <a:rPr sz="4200"/>
+              <a:t>Preteen suicide (ages 8+): 8.2% annual increase (2008-2022).</a:t>
+            </a:r>
+          </a:p>
+          <a:p>
+            <a:r>
+              <a:rPr sz="4200"/>
+              <a:t>More therapists, more spending, more awareness than ever.</a:t>
+            </a:r>
           </a:p>
         </p:txBody>
       </p:sp>
@@ -2461,10 +3036,39 @@
           <a:lstStyle/>
           <a:p>
             <a:r>
-              <a:rPr lang="en-US" dirty="0"/>
-              <a:t/>
-            </a:r>
-            <a:endParaRPr lang="en-US" dirty="0"/>
+              <a:rPr sz="4200"/>
+              <a:t>THE REPLICATION CRISIS + INSTITUTIONAL LOSS OF CONFIDENCE</a:t>
+            </a:r>
+          </a:p>
+          <a:p>
+            <a:r>
+              <a:rPr sz="4200"/>
+              <a:t>Source: Northwestern IPR</a:t>
+            </a:r>
+          </a:p>
+          <a:p>
+            <a:r>
+              <a:rPr sz="4200"/>
+              <a:t>~40% of psychology studies replicate. "The research base itself is unreliable."</a:t>
+            </a:r>
+          </a:p>
+          <a:p>
+            <a:r>
+              <a:rPr sz="4200"/>
+              <a:t>NIMH stopped funding DSM-only research (2013).</a:t>
+            </a:r>
+          </a:p>
+          <a:p>
+            <a:r>
+              <a:rPr sz="4200"/>
+              <a:t>Thomas Insel: DSM diagnoses are "consensus about clusters of clinical symptoms, not any objective laboratory measure."</a:t>
+            </a:r>
+          </a:p>
+          <a:p>
+            <a:r>
+              <a:rPr sz="4200"/>
+              <a:t>"The field's own institutions have lost confidence in its diagnostic framework."</a:t>
+            </a:r>
           </a:p>
         </p:txBody>
       </p:sp>
@@ -2549,10 +3153,45 @@
           <a:lstStyle/>
           <a:p>
             <a:r>
-              <a:rPr lang="en-US" dirty="0"/>
-              <a:t/>
-            </a:r>
-            <a:endParaRPr lang="en-US" dirty="0"/>
+              <a:rPr sz="4200"/>
+              <a:t>PUBLIC SKEPTICISM</a:t>
+            </a:r>
+          </a:p>
+          <a:p>
+            <a:r>
+              <a:rPr sz="4200"/>
+              <a:t>Source: Roper Center / Psychology Today polls</a:t>
+            </a:r>
+          </a:p>
+          <a:p>
+            <a:r>
+              <a:rPr sz="4200"/>
+              <a:t>43% say costs of therapy outweigh benefits (2004).</a:t>
+            </a:r>
+          </a:p>
+          <a:p>
+            <a:r>
+              <a:rPr sz="4200"/>
+              <a:t>38% believe most therapists need therapy themselves (2004).</a:t>
+            </a:r>
+          </a:p>
+          <a:p>
+            <a:r>
+              <a:rPr sz="4200"/>
+              <a:t>Public perceives therapy effective in only 26-50% of cases.</a:t>
+            </a:r>
+          </a:p>
+          <a:p>
+            <a:r>
+              <a:rPr sz="4200"/>
+              <a:t>"The public senses something is wrong—even if they can't articulate it. This skepticism has a basis."</a:t>
+            </a:r>
+          </a:p>
+          <a:p>
+            <a:r>
+              <a:rPr sz="4200"/>
+              <a:t>Transition: "How does a field stay broken this long? Let me show you a pattern."</a:t>
+            </a:r>
           </a:p>
         </p:txBody>
       </p:sp>
@@ -2637,10 +3276,15 @@
           <a:lstStyle/>
           <a:p>
             <a:r>
-              <a:rPr lang="en-US" dirty="0"/>
-              <a:t/>
-            </a:r>
-            <a:endParaRPr lang="en-US" dirty="0"/>
+              <a:rPr sz="4200"/>
+              <a:t>SECTION III: HISTORICAL CATASTROPHES (14 min)</a:t>
+            </a:r>
+          </a:p>
+          <a:p>
+            <a:r>
+              <a:rPr sz="4200"/>
+              <a:t>Setup: These aren't ancient history. These are cases where caring professionals, lacking objective frameworks, got swept up in collective beliefs that destroyed lives. The pattern repeats because the conditions repeat.</a:t>
+            </a:r>
           </a:p>
         </p:txBody>
       </p:sp>

</xml_diff>